<commit_message>
add category func into clear.py and updated ppt
</commit_message>
<xml_diff>
--- a/程式介紹與展示.pptx
+++ b/程式介紹與展示.pptx
@@ -5,7 +5,7 @@
     <p:sldMasterId id="2147483674" r:id="rId1"/>
   </p:sldMasterIdLst>
   <p:notesMasterIdLst>
-    <p:notesMasterId r:id="rId14"/>
+    <p:notesMasterId r:id="rId13"/>
   </p:notesMasterIdLst>
   <p:sldIdLst>
     <p:sldId id="256" r:id="rId2"/>
@@ -15,35 +15,34 @@
     <p:sldId id="306" r:id="rId6"/>
     <p:sldId id="307" r:id="rId7"/>
     <p:sldId id="304" r:id="rId8"/>
-    <p:sldId id="308" r:id="rId9"/>
-    <p:sldId id="257" r:id="rId10"/>
-    <p:sldId id="309" r:id="rId11"/>
-    <p:sldId id="261" r:id="rId12"/>
-    <p:sldId id="284" r:id="rId13"/>
+    <p:sldId id="257" r:id="rId9"/>
+    <p:sldId id="310" r:id="rId10"/>
+    <p:sldId id="261" r:id="rId11"/>
+    <p:sldId id="284" r:id="rId12"/>
   </p:sldIdLst>
   <p:sldSz cx="9144000" cy="5143500" type="screen16x9"/>
   <p:notesSz cx="6858000" cy="9144000"/>
   <p:embeddedFontLst>
     <p:embeddedFont>
-      <p:font typeface="Bebas Neue" panose="02020500000000000000" charset="0"/>
-      <p:regular r:id="rId15"/>
+      <p:font typeface="Bebas Neue" panose="020B0606020202050201" pitchFamily="34" charset="0"/>
+      <p:regular r:id="rId14"/>
     </p:embeddedFont>
     <p:embeddedFont>
       <p:font typeface="Mulish" panose="02020500000000000000" charset="0"/>
-      <p:regular r:id="rId16"/>
-      <p:bold r:id="rId17"/>
-      <p:italic r:id="rId18"/>
-      <p:boldItalic r:id="rId19"/>
+      <p:regular r:id="rId15"/>
+      <p:bold r:id="rId16"/>
+      <p:italic r:id="rId17"/>
+      <p:boldItalic r:id="rId18"/>
     </p:embeddedFont>
     <p:embeddedFont>
-      <p:font typeface="Nunito Light" panose="02020500000000000000" charset="0"/>
-      <p:regular r:id="rId20"/>
-      <p:italic r:id="rId21"/>
+      <p:font typeface="Nunito Light" pitchFamily="2" charset="0"/>
+      <p:regular r:id="rId19"/>
+      <p:italic r:id="rId20"/>
     </p:embeddedFont>
     <p:embeddedFont>
       <p:font typeface="Quicksand" panose="02020500000000000000" charset="0"/>
-      <p:regular r:id="rId22"/>
-      <p:bold r:id="rId23"/>
+      <p:regular r:id="rId21"/>
+      <p:bold r:id="rId22"/>
     </p:embeddedFont>
   </p:embeddedFontLst>
   <p:defaultTextStyle>
@@ -859,13 +858,7 @@
   <p:cSld>
     <p:spTree>
       <p:nvGrpSpPr>
-        <p:cNvPr id="1" name="Shape 349">
-          <a:extLst>
-            <a:ext uri="{FF2B5EF4-FFF2-40B4-BE49-F238E27FC236}">
-              <a16:creationId xmlns:a16="http://schemas.microsoft.com/office/drawing/2014/main" id="{4B8B47C6-0DE6-7E5D-DDE9-57518D26E18D}"/>
-            </a:ext>
-          </a:extLst>
-        </p:cNvPr>
+        <p:cNvPr id="1" name="Shape 349"/>
         <p:cNvGrpSpPr/>
         <p:nvPr/>
       </p:nvGrpSpPr>
@@ -879,13 +872,7 @@
       </p:grpSpPr>
       <p:sp>
         <p:nvSpPr>
-          <p:cNvPr id="350" name="Google Shape;350;ged9256fe6f_0_23:notes">
-            <a:extLst>
-              <a:ext uri="{FF2B5EF4-FFF2-40B4-BE49-F238E27FC236}">
-                <a16:creationId xmlns:a16="http://schemas.microsoft.com/office/drawing/2014/main" id="{8139641A-7950-E38F-F172-4F8A5250E8AE}"/>
-              </a:ext>
-            </a:extLst>
-          </p:cNvPr>
+          <p:cNvPr id="350" name="Google Shape;350;ged9256fe6f_0_23:notes"/>
           <p:cNvSpPr>
             <a:spLocks noGrp="1" noRot="1" noChangeAspect="1"/>
           </p:cNvSpPr>
@@ -933,128 +920,6 @@
       </p:sp>
       <p:sp>
         <p:nvSpPr>
-          <p:cNvPr id="351" name="Google Shape;351;ged9256fe6f_0_23:notes">
-            <a:extLst>
-              <a:ext uri="{FF2B5EF4-FFF2-40B4-BE49-F238E27FC236}">
-                <a16:creationId xmlns:a16="http://schemas.microsoft.com/office/drawing/2014/main" id="{07C478F5-38FF-FCC6-6B02-3A98895327D3}"/>
-              </a:ext>
-            </a:extLst>
-          </p:cNvPr>
-          <p:cNvSpPr txBox="1">
-            <a:spLocks noGrp="1"/>
-          </p:cNvSpPr>
-          <p:nvPr>
-            <p:ph type="body" idx="1"/>
-          </p:nvPr>
-        </p:nvSpPr>
-        <p:spPr>
-          <a:xfrm>
-            <a:off x="685800" y="4343400"/>
-            <a:ext cx="5486400" cy="4114800"/>
-          </a:xfrm>
-          <a:prstGeom prst="rect">
-            <a:avLst/>
-          </a:prstGeom>
-        </p:spPr>
-        <p:txBody>
-          <a:bodyPr spcFirstLastPara="1" wrap="square" lIns="91425" tIns="91425" rIns="91425" bIns="91425" anchor="t" anchorCtr="0">
-            <a:noAutofit/>
-          </a:bodyPr>
-          <a:lstStyle/>
-          <a:p>
-            <a:pPr marL="0" lvl="0" indent="0" algn="l" rtl="0">
-              <a:spcBef>
-                <a:spcPts val="0"/>
-              </a:spcBef>
-              <a:spcAft>
-                <a:spcPts val="0"/>
-              </a:spcAft>
-              <a:buNone/>
-            </a:pPr>
-            <a:endParaRPr/>
-          </a:p>
-        </p:txBody>
-      </p:sp>
-    </p:spTree>
-    <p:extLst>
-      <p:ext uri="{BB962C8B-B14F-4D97-AF65-F5344CB8AC3E}">
-        <p14:creationId xmlns:p14="http://schemas.microsoft.com/office/powerpoint/2010/main" val="2083211988"/>
-      </p:ext>
-    </p:extLst>
-  </p:cSld>
-  <p:clrMapOvr>
-    <a:masterClrMapping/>
-  </p:clrMapOvr>
-</p:notes>
-</file>
-
-<file path=ppt/notesSlides/notesSlide11.xml><?xml version="1.0" encoding="utf-8"?>
-<p:notes xmlns:a="http://schemas.openxmlformats.org/drawingml/2006/main" xmlns:r="http://schemas.openxmlformats.org/officeDocument/2006/relationships" xmlns:p="http://schemas.openxmlformats.org/presentationml/2006/main" showMasterSp="0" showMasterPhAnim="0">
-  <p:cSld>
-    <p:spTree>
-      <p:nvGrpSpPr>
-        <p:cNvPr id="1" name="Shape 349"/>
-        <p:cNvGrpSpPr/>
-        <p:nvPr/>
-      </p:nvGrpSpPr>
-      <p:grpSpPr>
-        <a:xfrm>
-          <a:off x="0" y="0"/>
-          <a:ext cx="0" cy="0"/>
-          <a:chOff x="0" y="0"/>
-          <a:chExt cx="0" cy="0"/>
-        </a:xfrm>
-      </p:grpSpPr>
-      <p:sp>
-        <p:nvSpPr>
-          <p:cNvPr id="350" name="Google Shape;350;ged9256fe6f_0_23:notes"/>
-          <p:cNvSpPr>
-            <a:spLocks noGrp="1" noRot="1" noChangeAspect="1"/>
-          </p:cNvSpPr>
-          <p:nvPr>
-            <p:ph type="sldImg" idx="2"/>
-          </p:nvPr>
-        </p:nvSpPr>
-        <p:spPr>
-          <a:xfrm>
-            <a:off x="381000" y="685800"/>
-            <a:ext cx="6096000" cy="3429000"/>
-          </a:xfrm>
-          <a:custGeom>
-            <a:avLst/>
-            <a:gdLst/>
-            <a:ahLst/>
-            <a:cxnLst/>
-            <a:rect l="l" t="t" r="r" b="b"/>
-            <a:pathLst>
-              <a:path w="120000" h="120000" extrusionOk="0">
-                <a:moveTo>
-                  <a:pt x="0" y="0"/>
-                </a:moveTo>
-                <a:lnTo>
-                  <a:pt x="120000" y="0"/>
-                </a:lnTo>
-                <a:lnTo>
-                  <a:pt x="120000" y="120000"/>
-                </a:lnTo>
-                <a:lnTo>
-                  <a:pt x="0" y="120000"/>
-                </a:lnTo>
-                <a:close/>
-              </a:path>
-            </a:pathLst>
-          </a:custGeom>
-        </p:spPr>
-        <p:txBody>
-          <a:bodyPr/>
-          <a:lstStyle/>
-          <a:p>
-            <a:endParaRPr lang="zh-TW" altLang="en-US"/>
-          </a:p>
-        </p:txBody>
-      </p:sp>
-      <p:sp>
-        <p:nvSpPr>
           <p:cNvPr id="351" name="Google Shape;351;ged9256fe6f_0_23:notes"/>
           <p:cNvSpPr txBox="1">
             <a:spLocks noGrp="1"/>
@@ -1099,7 +964,7 @@
 </p:notes>
 </file>
 
-<file path=ppt/notesSlides/notesSlide12.xml><?xml version="1.0" encoding="utf-8"?>
+<file path=ppt/notesSlides/notesSlide11.xml><?xml version="1.0" encoding="utf-8"?>
 <p:notes xmlns:a="http://schemas.openxmlformats.org/drawingml/2006/main" xmlns:r="http://schemas.openxmlformats.org/officeDocument/2006/relationships" xmlns:p="http://schemas.openxmlformats.org/presentationml/2006/main" showMasterSp="0" showMasterPhAnim="0">
   <p:cSld>
     <p:spTree>
@@ -1905,13 +1770,7 @@
   <p:cSld>
     <p:spTree>
       <p:nvGrpSpPr>
-        <p:cNvPr id="1" name="Shape 349">
-          <a:extLst>
-            <a:ext uri="{FF2B5EF4-FFF2-40B4-BE49-F238E27FC236}">
-              <a16:creationId xmlns:a16="http://schemas.microsoft.com/office/drawing/2014/main" id="{4B8B47C6-0DE6-7E5D-DDE9-57518D26E18D}"/>
-            </a:ext>
-          </a:extLst>
-        </p:cNvPr>
+        <p:cNvPr id="1" name="Shape 291"/>
         <p:cNvGrpSpPr/>
         <p:nvPr/>
       </p:nvGrpSpPr>
@@ -1925,13 +1784,7 @@
       </p:grpSpPr>
       <p:sp>
         <p:nvSpPr>
-          <p:cNvPr id="350" name="Google Shape;350;ged9256fe6f_0_23:notes">
-            <a:extLst>
-              <a:ext uri="{FF2B5EF4-FFF2-40B4-BE49-F238E27FC236}">
-                <a16:creationId xmlns:a16="http://schemas.microsoft.com/office/drawing/2014/main" id="{8139641A-7950-E38F-F172-4F8A5250E8AE}"/>
-              </a:ext>
-            </a:extLst>
-          </p:cNvPr>
+          <p:cNvPr id="292" name="Google Shape;292;g133f6155f6d_0_3:notes"/>
           <p:cNvSpPr>
             <a:spLocks noGrp="1" noRot="1" noChangeAspect="1"/>
           </p:cNvSpPr>
@@ -1979,13 +1832,7 @@
       </p:sp>
       <p:sp>
         <p:nvSpPr>
-          <p:cNvPr id="351" name="Google Shape;351;ged9256fe6f_0_23:notes">
-            <a:extLst>
-              <a:ext uri="{FF2B5EF4-FFF2-40B4-BE49-F238E27FC236}">
-                <a16:creationId xmlns:a16="http://schemas.microsoft.com/office/drawing/2014/main" id="{07C478F5-38FF-FCC6-6B02-3A98895327D3}"/>
-              </a:ext>
-            </a:extLst>
-          </p:cNvPr>
+          <p:cNvPr id="293" name="Google Shape;293;g133f6155f6d_0_3:notes"/>
           <p:cNvSpPr txBox="1">
             <a:spLocks noGrp="1"/>
           </p:cNvSpPr>
@@ -2022,11 +1869,6 @@
         </p:txBody>
       </p:sp>
     </p:spTree>
-    <p:extLst>
-      <p:ext uri="{BB962C8B-B14F-4D97-AF65-F5344CB8AC3E}">
-        <p14:creationId xmlns:p14="http://schemas.microsoft.com/office/powerpoint/2010/main" val="3265544753"/>
-      </p:ext>
-    </p:extLst>
   </p:cSld>
   <p:clrMapOvr>
     <a:masterClrMapping/>
@@ -2039,7 +1881,13 @@
   <p:cSld>
     <p:spTree>
       <p:nvGrpSpPr>
-        <p:cNvPr id="1" name="Shape 291"/>
+        <p:cNvPr id="1" name="Shape 291">
+          <a:extLst>
+            <a:ext uri="{FF2B5EF4-FFF2-40B4-BE49-F238E27FC236}">
+              <a16:creationId xmlns:a16="http://schemas.microsoft.com/office/drawing/2014/main" id="{CA010337-7295-458C-92FB-2A5E6BE1BAE8}"/>
+            </a:ext>
+          </a:extLst>
+        </p:cNvPr>
         <p:cNvGrpSpPr/>
         <p:nvPr/>
       </p:nvGrpSpPr>
@@ -2053,7 +1901,13 @@
       </p:grpSpPr>
       <p:sp>
         <p:nvSpPr>
-          <p:cNvPr id="292" name="Google Shape;292;g133f6155f6d_0_3:notes"/>
+          <p:cNvPr id="292" name="Google Shape;292;g133f6155f6d_0_3:notes">
+            <a:extLst>
+              <a:ext uri="{FF2B5EF4-FFF2-40B4-BE49-F238E27FC236}">
+                <a16:creationId xmlns:a16="http://schemas.microsoft.com/office/drawing/2014/main" id="{DD9AB43E-4FE1-9B79-448D-612144D91DF0}"/>
+              </a:ext>
+            </a:extLst>
+          </p:cNvPr>
           <p:cNvSpPr>
             <a:spLocks noGrp="1" noRot="1" noChangeAspect="1"/>
           </p:cNvSpPr>
@@ -2101,7 +1955,13 @@
       </p:sp>
       <p:sp>
         <p:nvSpPr>
-          <p:cNvPr id="293" name="Google Shape;293;g133f6155f6d_0_3:notes"/>
+          <p:cNvPr id="293" name="Google Shape;293;g133f6155f6d_0_3:notes">
+            <a:extLst>
+              <a:ext uri="{FF2B5EF4-FFF2-40B4-BE49-F238E27FC236}">
+                <a16:creationId xmlns:a16="http://schemas.microsoft.com/office/drawing/2014/main" id="{48E729D9-8EA5-D7B1-7369-3220C4EC4CC8}"/>
+              </a:ext>
+            </a:extLst>
+          </p:cNvPr>
           <p:cNvSpPr txBox="1">
             <a:spLocks noGrp="1"/>
           </p:cNvSpPr>
@@ -2138,6 +1998,11 @@
         </p:txBody>
       </p:sp>
     </p:spTree>
+    <p:extLst>
+      <p:ext uri="{BB962C8B-B14F-4D97-AF65-F5344CB8AC3E}">
+        <p14:creationId xmlns:p14="http://schemas.microsoft.com/office/powerpoint/2010/main" val="2195808436"/>
+      </p:ext>
+    </p:extLst>
   </p:cSld>
   <p:clrMapOvr>
     <a:masterClrMapping/>
@@ -12633,176 +12498,6 @@
   <p:cSld>
     <p:spTree>
       <p:nvGrpSpPr>
-        <p:cNvPr id="1" name="Shape 352">
-          <a:extLst>
-            <a:ext uri="{FF2B5EF4-FFF2-40B4-BE49-F238E27FC236}">
-              <a16:creationId xmlns:a16="http://schemas.microsoft.com/office/drawing/2014/main" id="{F5B0BC03-2AA9-600D-FBBE-77D998CEAE9E}"/>
-            </a:ext>
-          </a:extLst>
-        </p:cNvPr>
-        <p:cNvGrpSpPr/>
-        <p:nvPr/>
-      </p:nvGrpSpPr>
-      <p:grpSpPr>
-        <a:xfrm>
-          <a:off x="0" y="0"/>
-          <a:ext cx="0" cy="0"/>
-          <a:chOff x="0" y="0"/>
-          <a:chExt cx="0" cy="0"/>
-        </a:xfrm>
-      </p:grpSpPr>
-      <p:sp>
-        <p:nvSpPr>
-          <p:cNvPr id="355" name="Google Shape;355;p34">
-            <a:extLst>
-              <a:ext uri="{FF2B5EF4-FFF2-40B4-BE49-F238E27FC236}">
-                <a16:creationId xmlns:a16="http://schemas.microsoft.com/office/drawing/2014/main" id="{4A7A125A-0EE4-A7D0-00F1-EFBA1EC76214}"/>
-              </a:ext>
-            </a:extLst>
-          </p:cNvPr>
-          <p:cNvSpPr txBox="1">
-            <a:spLocks noGrp="1"/>
-          </p:cNvSpPr>
-          <p:nvPr>
-            <p:ph type="sldNum" idx="12"/>
-          </p:nvPr>
-        </p:nvSpPr>
-        <p:spPr>
-          <a:xfrm>
-            <a:off x="4297650" y="4602875"/>
-            <a:ext cx="548700" cy="333600"/>
-          </a:xfrm>
-          <a:prstGeom prst="rect">
-            <a:avLst/>
-          </a:prstGeom>
-        </p:spPr>
-        <p:txBody>
-          <a:bodyPr spcFirstLastPara="1" wrap="square" lIns="91425" tIns="91425" rIns="91425" bIns="91425" anchor="t" anchorCtr="0">
-            <a:noAutofit/>
-          </a:bodyPr>
-          <a:lstStyle/>
-          <a:p>
-            <a:pPr marL="0" lvl="0" indent="0" algn="ctr" rtl="0">
-              <a:spcBef>
-                <a:spcPts val="0"/>
-              </a:spcBef>
-              <a:spcAft>
-                <a:spcPts val="0"/>
-              </a:spcAft>
-              <a:buNone/>
-            </a:pPr>
-            <a:r>
-              <a:rPr lang="en-US" altLang="zh-TW" dirty="0"/>
-              <a:t>9</a:t>
-            </a:r>
-            <a:endParaRPr dirty="0"/>
-          </a:p>
-        </p:txBody>
-      </p:sp>
-      <p:sp>
-        <p:nvSpPr>
-          <p:cNvPr id="14" name="文字方塊 13">
-            <a:extLst>
-              <a:ext uri="{FF2B5EF4-FFF2-40B4-BE49-F238E27FC236}">
-                <a16:creationId xmlns:a16="http://schemas.microsoft.com/office/drawing/2014/main" id="{E7C98D4C-83D3-20C7-FEBF-D561132C09C7}"/>
-              </a:ext>
-            </a:extLst>
-          </p:cNvPr>
-          <p:cNvSpPr txBox="1"/>
-          <p:nvPr/>
-        </p:nvSpPr>
-        <p:spPr>
-          <a:xfrm>
-            <a:off x="2286000" y="376464"/>
-            <a:ext cx="4572000" cy="523220"/>
-          </a:xfrm>
-          <a:prstGeom prst="rect">
-            <a:avLst/>
-          </a:prstGeom>
-          <a:noFill/>
-        </p:spPr>
-        <p:txBody>
-          <a:bodyPr wrap="square">
-            <a:spAutoFit/>
-          </a:bodyPr>
-          <a:lstStyle/>
-          <a:p>
-            <a:pPr algn="ctr"/>
-            <a:r>
-              <a:rPr lang="zh-TW" altLang="en-US" sz="2800" dirty="0">
-                <a:ln w="0"/>
-                <a:gradFill>
-                  <a:gsLst>
-                    <a:gs pos="21000">
-                      <a:srgbClr val="53575C"/>
-                    </a:gs>
-                    <a:gs pos="88000">
-                      <a:srgbClr val="C5C7CA"/>
-                    </a:gs>
-                  </a:gsLst>
-                  <a:lin ang="5400000"/>
-                </a:gradFill>
-              </a:rPr>
-              <a:t>圖表展示</a:t>
-            </a:r>
-          </a:p>
-        </p:txBody>
-      </p:sp>
-      <p:pic>
-        <p:nvPicPr>
-          <p:cNvPr id="3" name="圖片 2">
-            <a:extLst>
-              <a:ext uri="{FF2B5EF4-FFF2-40B4-BE49-F238E27FC236}">
-                <a16:creationId xmlns:a16="http://schemas.microsoft.com/office/drawing/2014/main" id="{4A6B7435-C897-4B5A-817A-96EF38533240}"/>
-              </a:ext>
-            </a:extLst>
-          </p:cNvPr>
-          <p:cNvPicPr>
-            <a:picLocks noChangeAspect="1"/>
-          </p:cNvPicPr>
-          <p:nvPr/>
-        </p:nvPicPr>
-        <p:blipFill>
-          <a:blip r:embed="rId3"/>
-          <a:stretch>
-            <a:fillRect/>
-          </a:stretch>
-        </p:blipFill>
-        <p:spPr>
-          <a:xfrm>
-            <a:off x="1221426" y="833556"/>
-            <a:ext cx="6722196" cy="3835447"/>
-          </a:xfrm>
-          <a:prstGeom prst="rect">
-            <a:avLst/>
-          </a:prstGeom>
-          <a:ln w="12700">
-            <a:solidFill>
-              <a:schemeClr val="bg1">
-                <a:lumMod val="10000"/>
-              </a:schemeClr>
-            </a:solidFill>
-          </a:ln>
-        </p:spPr>
-      </p:pic>
-    </p:spTree>
-    <p:extLst>
-      <p:ext uri="{BB962C8B-B14F-4D97-AF65-F5344CB8AC3E}">
-        <p14:creationId xmlns:p14="http://schemas.microsoft.com/office/powerpoint/2010/main" val="241514042"/>
-      </p:ext>
-    </p:extLst>
-  </p:cSld>
-  <p:clrMapOvr>
-    <a:masterClrMapping/>
-  </p:clrMapOvr>
-</p:sld>
-</file>
-
-<file path=ppt/slides/slide11.xml><?xml version="1.0" encoding="utf-8"?>
-<p:sld xmlns:a="http://schemas.openxmlformats.org/drawingml/2006/main" xmlns:r="http://schemas.openxmlformats.org/officeDocument/2006/relationships" xmlns:p="http://schemas.openxmlformats.org/presentationml/2006/main">
-  <p:cSld>
-    <p:spTree>
-      <p:nvGrpSpPr>
         <p:cNvPr id="1" name="Shape 352"/>
         <p:cNvGrpSpPr/>
         <p:nvPr/>
@@ -13039,7 +12734,7 @@
 </p:sld>
 </file>
 
-<file path=ppt/slides/slide12.xml><?xml version="1.0" encoding="utf-8"?>
+<file path=ppt/slides/slide11.xml><?xml version="1.0" encoding="utf-8"?>
 <p:sld xmlns:a="http://schemas.openxmlformats.org/drawingml/2006/main" xmlns:r="http://schemas.openxmlformats.org/officeDocument/2006/relationships" xmlns:p="http://schemas.openxmlformats.org/presentationml/2006/main">
   <p:cSld>
     <p:spTree>
@@ -14893,7 +14588,7 @@
         </p:nvSpPr>
         <p:spPr>
           <a:xfrm>
-            <a:off x="1642873" y="2601468"/>
+            <a:off x="1642873" y="2351532"/>
             <a:ext cx="2350008" cy="1169551"/>
           </a:xfrm>
           <a:prstGeom prst="rect">
@@ -15328,6 +15023,79 @@
           </a:p>
         </p:txBody>
       </p:sp>
+      <p:sp>
+        <p:nvSpPr>
+          <p:cNvPr id="2" name="文字方塊 1">
+            <a:extLst>
+              <a:ext uri="{FF2B5EF4-FFF2-40B4-BE49-F238E27FC236}">
+                <a16:creationId xmlns:a16="http://schemas.microsoft.com/office/drawing/2014/main" id="{A2D5AFB7-4AAB-7B8F-309B-7C337574D8E0}"/>
+              </a:ext>
+            </a:extLst>
+          </p:cNvPr>
+          <p:cNvSpPr txBox="1"/>
+          <p:nvPr/>
+        </p:nvSpPr>
+        <p:spPr>
+          <a:xfrm>
+            <a:off x="1642873" y="3521083"/>
+            <a:ext cx="2807208" cy="954107"/>
+          </a:xfrm>
+          <a:prstGeom prst="rect">
+            <a:avLst/>
+          </a:prstGeom>
+          <a:noFill/>
+        </p:spPr>
+        <p:txBody>
+          <a:bodyPr wrap="square" rtlCol="0">
+            <a:spAutoFit/>
+          </a:bodyPr>
+          <a:lstStyle/>
+          <a:p>
+            <a:r>
+              <a:rPr lang="en-US" altLang="zh-TW" dirty="0"/>
+              <a:t>Why output csv instead of graph?</a:t>
+            </a:r>
+          </a:p>
+          <a:p>
+            <a:r>
+              <a:rPr lang="zh-TW" altLang="en-US" dirty="0"/>
+              <a:t>我可以使用 </a:t>
+            </a:r>
+            <a:r>
+              <a:rPr lang="en-US" altLang="zh-TW" dirty="0"/>
+              <a:t>.csv </a:t>
+            </a:r>
+            <a:r>
+              <a:rPr lang="zh-TW" altLang="en-US" dirty="0"/>
+              <a:t>快速的製作任何有特定需求的圖表</a:t>
+            </a:r>
+            <a:r>
+              <a:rPr lang="en-US" altLang="zh-TW" dirty="0"/>
+              <a:t>, </a:t>
+            </a:r>
+            <a:r>
+              <a:rPr lang="zh-TW" altLang="en-US" dirty="0"/>
+              <a:t>相反地</a:t>
+            </a:r>
+            <a:r>
+              <a:rPr lang="en-US" altLang="zh-TW" dirty="0"/>
+              <a:t>, </a:t>
+            </a:r>
+            <a:r>
+              <a:rPr lang="zh-TW" altLang="en-US" dirty="0"/>
+              <a:t>將圖表製作成 </a:t>
+            </a:r>
+            <a:r>
+              <a:rPr lang="en-US" altLang="zh-TW" dirty="0"/>
+              <a:t>.csv</a:t>
+            </a:r>
+            <a:r>
+              <a:rPr lang="zh-TW" altLang="en-US" dirty="0"/>
+              <a:t> 會很不方便</a:t>
+            </a:r>
+          </a:p>
+        </p:txBody>
+      </p:sp>
     </p:spTree>
   </p:cSld>
   <p:clrMapOvr>
@@ -18171,11 +17939,11 @@
       </p:sp>
       <p:pic>
         <p:nvPicPr>
-          <p:cNvPr id="4" name="Picture" title="This slide contains the following visuals: textbox ,textbox ,Top 15 Skills ,Top 15 Tools. Please refer to the notes on this slide for details">
+          <p:cNvPr id="2" name="Picture" title="This slide contains the following visuals: textbox ,textbox ,Top 15 Skills ,Top 15 Tools. Please refer to the notes on this slide for details">
             <a:hlinkClick r:id="rId3"/>
             <a:extLst>
               <a:ext uri="{FF2B5EF4-FFF2-40B4-BE49-F238E27FC236}">
-                <a16:creationId xmlns:a16="http://schemas.microsoft.com/office/drawing/2014/main" id="{44AF0090-901E-A0E3-95CB-DFDBC29E897D}"/>
+                <a16:creationId xmlns:a16="http://schemas.microsoft.com/office/drawing/2014/main" id="{3F28D09B-E7A6-BD85-D95D-B3411043D09E}"/>
               </a:ext>
             </a:extLst>
           </p:cNvPr>
@@ -18186,15 +17954,15 @@
         </p:nvPicPr>
         <p:blipFill>
           <a:blip r:embed="rId4"/>
-          <a:srcRect t="3274" r="1344" b="6425"/>
+          <a:srcRect l="1390" t="3676" r="2444" b="7822"/>
           <a:stretch>
             <a:fillRect/>
           </a:stretch>
         </p:blipFill>
         <p:spPr>
           <a:xfrm>
-            <a:off x="973112" y="927127"/>
-            <a:ext cx="7197777" cy="3758638"/>
+            <a:off x="940936" y="866027"/>
+            <a:ext cx="7262123" cy="3813048"/>
           </a:xfrm>
           <a:prstGeom prst="rect">
             <a:avLst/>
@@ -18223,213 +17991,6 @@
 </file>
 
 <file path=ppt/slides/slide8.xml><?xml version="1.0" encoding="utf-8"?>
-<p:sld xmlns:a="http://schemas.openxmlformats.org/drawingml/2006/main" xmlns:r="http://schemas.openxmlformats.org/officeDocument/2006/relationships" xmlns:p="http://schemas.openxmlformats.org/presentationml/2006/main">
-  <p:cSld>
-    <p:spTree>
-      <p:nvGrpSpPr>
-        <p:cNvPr id="1" name="Shape 352">
-          <a:extLst>
-            <a:ext uri="{FF2B5EF4-FFF2-40B4-BE49-F238E27FC236}">
-              <a16:creationId xmlns:a16="http://schemas.microsoft.com/office/drawing/2014/main" id="{F5B0BC03-2AA9-600D-FBBE-77D998CEAE9E}"/>
-            </a:ext>
-          </a:extLst>
-        </p:cNvPr>
-        <p:cNvGrpSpPr/>
-        <p:nvPr/>
-      </p:nvGrpSpPr>
-      <p:grpSpPr>
-        <a:xfrm>
-          <a:off x="0" y="0"/>
-          <a:ext cx="0" cy="0"/>
-          <a:chOff x="0" y="0"/>
-          <a:chExt cx="0" cy="0"/>
-        </a:xfrm>
-      </p:grpSpPr>
-      <p:sp>
-        <p:nvSpPr>
-          <p:cNvPr id="355" name="Google Shape;355;p34">
-            <a:extLst>
-              <a:ext uri="{FF2B5EF4-FFF2-40B4-BE49-F238E27FC236}">
-                <a16:creationId xmlns:a16="http://schemas.microsoft.com/office/drawing/2014/main" id="{4A7A125A-0EE4-A7D0-00F1-EFBA1EC76214}"/>
-              </a:ext>
-            </a:extLst>
-          </p:cNvPr>
-          <p:cNvSpPr txBox="1">
-            <a:spLocks noGrp="1"/>
-          </p:cNvSpPr>
-          <p:nvPr>
-            <p:ph type="sldNum" idx="12"/>
-          </p:nvPr>
-        </p:nvSpPr>
-        <p:spPr>
-          <a:xfrm>
-            <a:off x="4297650" y="4602875"/>
-            <a:ext cx="548700" cy="333600"/>
-          </a:xfrm>
-          <a:prstGeom prst="rect">
-            <a:avLst/>
-          </a:prstGeom>
-        </p:spPr>
-        <p:txBody>
-          <a:bodyPr spcFirstLastPara="1" wrap="square" lIns="91425" tIns="91425" rIns="91425" bIns="91425" anchor="t" anchorCtr="0">
-            <a:noAutofit/>
-          </a:bodyPr>
-          <a:lstStyle/>
-          <a:p>
-            <a:pPr marL="0" lvl="0" indent="0" algn="ctr" rtl="0">
-              <a:spcBef>
-                <a:spcPts val="0"/>
-              </a:spcBef>
-              <a:spcAft>
-                <a:spcPts val="0"/>
-              </a:spcAft>
-              <a:buNone/>
-            </a:pPr>
-            <a:r>
-              <a:rPr lang="en" dirty="0"/>
-              <a:t>7</a:t>
-            </a:r>
-            <a:endParaRPr dirty="0"/>
-          </a:p>
-        </p:txBody>
-      </p:sp>
-      <p:pic>
-        <p:nvPicPr>
-          <p:cNvPr id="11" name="圖片 10">
-            <a:extLst>
-              <a:ext uri="{FF2B5EF4-FFF2-40B4-BE49-F238E27FC236}">
-                <a16:creationId xmlns:a16="http://schemas.microsoft.com/office/drawing/2014/main" id="{9137114D-2CD8-AD80-EACD-6589E5B1DE94}"/>
-              </a:ext>
-            </a:extLst>
-          </p:cNvPr>
-          <p:cNvPicPr>
-            <a:picLocks noChangeAspect="1"/>
-          </p:cNvPicPr>
-          <p:nvPr/>
-        </p:nvPicPr>
-        <p:blipFill>
-          <a:blip r:embed="rId3"/>
-          <a:stretch>
-            <a:fillRect/>
-          </a:stretch>
-        </p:blipFill>
-        <p:spPr>
-          <a:xfrm>
-            <a:off x="217898" y="967990"/>
-            <a:ext cx="4354101" cy="3510568"/>
-          </a:xfrm>
-          <a:prstGeom prst="rect">
-            <a:avLst/>
-          </a:prstGeom>
-          <a:ln>
-            <a:solidFill>
-              <a:schemeClr val="bg1">
-                <a:lumMod val="10000"/>
-              </a:schemeClr>
-            </a:solidFill>
-          </a:ln>
-        </p:spPr>
-      </p:pic>
-      <p:pic>
-        <p:nvPicPr>
-          <p:cNvPr id="13" name="圖片 12">
-            <a:extLst>
-              <a:ext uri="{FF2B5EF4-FFF2-40B4-BE49-F238E27FC236}">
-                <a16:creationId xmlns:a16="http://schemas.microsoft.com/office/drawing/2014/main" id="{0DB0C4A7-E7E1-0F2F-2A0A-80B1216CA969}"/>
-              </a:ext>
-            </a:extLst>
-          </p:cNvPr>
-          <p:cNvPicPr>
-            <a:picLocks noChangeAspect="1"/>
-          </p:cNvPicPr>
-          <p:nvPr/>
-        </p:nvPicPr>
-        <p:blipFill>
-          <a:blip r:embed="rId4"/>
-          <a:stretch>
-            <a:fillRect/>
-          </a:stretch>
-        </p:blipFill>
-        <p:spPr>
-          <a:xfrm>
-            <a:off x="4572000" y="967990"/>
-            <a:ext cx="4354100" cy="3510567"/>
-          </a:xfrm>
-          <a:prstGeom prst="rect">
-            <a:avLst/>
-          </a:prstGeom>
-          <a:ln>
-            <a:solidFill>
-              <a:schemeClr val="bg1">
-                <a:lumMod val="10000"/>
-              </a:schemeClr>
-            </a:solidFill>
-          </a:ln>
-        </p:spPr>
-      </p:pic>
-      <p:sp>
-        <p:nvSpPr>
-          <p:cNvPr id="14" name="文字方塊 13">
-            <a:extLst>
-              <a:ext uri="{FF2B5EF4-FFF2-40B4-BE49-F238E27FC236}">
-                <a16:creationId xmlns:a16="http://schemas.microsoft.com/office/drawing/2014/main" id="{E7C98D4C-83D3-20C7-FEBF-D561132C09C7}"/>
-              </a:ext>
-            </a:extLst>
-          </p:cNvPr>
-          <p:cNvSpPr txBox="1"/>
-          <p:nvPr/>
-        </p:nvSpPr>
-        <p:spPr>
-          <a:xfrm>
-            <a:off x="2286000" y="376464"/>
-            <a:ext cx="4572000" cy="523220"/>
-          </a:xfrm>
-          <a:prstGeom prst="rect">
-            <a:avLst/>
-          </a:prstGeom>
-          <a:noFill/>
-        </p:spPr>
-        <p:txBody>
-          <a:bodyPr wrap="square">
-            <a:spAutoFit/>
-          </a:bodyPr>
-          <a:lstStyle/>
-          <a:p>
-            <a:pPr algn="ctr"/>
-            <a:r>
-              <a:rPr lang="zh-TW" altLang="en-US" sz="2800" dirty="0">
-                <a:ln w="0"/>
-                <a:gradFill>
-                  <a:gsLst>
-                    <a:gs pos="21000">
-                      <a:srgbClr val="53575C"/>
-                    </a:gs>
-                    <a:gs pos="88000">
-                      <a:srgbClr val="C5C7CA"/>
-                    </a:gs>
-                  </a:gsLst>
-                  <a:lin ang="5400000"/>
-                </a:gradFill>
-              </a:rPr>
-              <a:t>圖表展示</a:t>
-            </a:r>
-          </a:p>
-        </p:txBody>
-      </p:sp>
-    </p:spTree>
-    <p:extLst>
-      <p:ext uri="{BB962C8B-B14F-4D97-AF65-F5344CB8AC3E}">
-        <p14:creationId xmlns:p14="http://schemas.microsoft.com/office/powerpoint/2010/main" val="2726357564"/>
-      </p:ext>
-    </p:extLst>
-  </p:cSld>
-  <p:clrMapOvr>
-    <a:masterClrMapping/>
-  </p:clrMapOvr>
-</p:sld>
-</file>
-
-<file path=ppt/slides/slide9.xml><?xml version="1.0" encoding="utf-8"?>
 <p:sld xmlns:a="http://schemas.openxmlformats.org/drawingml/2006/main" xmlns:r="http://schemas.openxmlformats.org/officeDocument/2006/relationships" xmlns:p="http://schemas.openxmlformats.org/presentationml/2006/main">
   <p:cSld>
     <p:spTree>
@@ -18539,10 +18100,10 @@
       </p:sp>
       <p:pic>
         <p:nvPicPr>
-          <p:cNvPr id="5" name="圖片 4">
+          <p:cNvPr id="3" name="圖片 2">
             <a:extLst>
               <a:ext uri="{FF2B5EF4-FFF2-40B4-BE49-F238E27FC236}">
-                <a16:creationId xmlns:a16="http://schemas.microsoft.com/office/drawing/2014/main" id="{9337E5DD-E7CA-FC86-1A6C-F11F55A44CDE}"/>
+                <a16:creationId xmlns:a16="http://schemas.microsoft.com/office/drawing/2014/main" id="{5ED34386-CE03-0960-55EC-08246B85BD21}"/>
               </a:ext>
             </a:extLst>
           </p:cNvPr>
@@ -18559,8 +18120,8 @@
         </p:blipFill>
         <p:spPr>
           <a:xfrm>
-            <a:off x="1118445" y="899684"/>
-            <a:ext cx="6907110" cy="3767515"/>
+            <a:off x="1502664" y="851485"/>
+            <a:ext cx="6138672" cy="3799589"/>
           </a:xfrm>
           <a:prstGeom prst="rect">
             <a:avLst/>
@@ -18575,6 +18136,213 @@
         </p:spPr>
       </p:pic>
     </p:spTree>
+  </p:cSld>
+  <p:clrMapOvr>
+    <a:masterClrMapping/>
+  </p:clrMapOvr>
+</p:sld>
+</file>
+
+<file path=ppt/slides/slide9.xml><?xml version="1.0" encoding="utf-8"?>
+<p:sld xmlns:a="http://schemas.openxmlformats.org/drawingml/2006/main" xmlns:r="http://schemas.openxmlformats.org/officeDocument/2006/relationships" xmlns:p="http://schemas.openxmlformats.org/presentationml/2006/main">
+  <p:cSld>
+    <p:spTree>
+      <p:nvGrpSpPr>
+        <p:cNvPr id="1" name="Shape 294">
+          <a:extLst>
+            <a:ext uri="{FF2B5EF4-FFF2-40B4-BE49-F238E27FC236}">
+              <a16:creationId xmlns:a16="http://schemas.microsoft.com/office/drawing/2014/main" id="{D049356B-CF66-52EB-6F65-01368B6BB8CA}"/>
+            </a:ext>
+          </a:extLst>
+        </p:cNvPr>
+        <p:cNvGrpSpPr/>
+        <p:nvPr/>
+      </p:nvGrpSpPr>
+      <p:grpSpPr>
+        <a:xfrm>
+          <a:off x="0" y="0"/>
+          <a:ext cx="0" cy="0"/>
+          <a:chOff x="0" y="0"/>
+          <a:chExt cx="0" cy="0"/>
+        </a:xfrm>
+      </p:grpSpPr>
+      <p:sp>
+        <p:nvSpPr>
+          <p:cNvPr id="300" name="Google Shape;300;p30">
+            <a:extLst>
+              <a:ext uri="{FF2B5EF4-FFF2-40B4-BE49-F238E27FC236}">
+                <a16:creationId xmlns:a16="http://schemas.microsoft.com/office/drawing/2014/main" id="{E64D6DD2-4C56-334A-6CDA-651F7C5714D8}"/>
+              </a:ext>
+            </a:extLst>
+          </p:cNvPr>
+          <p:cNvSpPr txBox="1">
+            <a:spLocks noGrp="1"/>
+          </p:cNvSpPr>
+          <p:nvPr>
+            <p:ph type="sldNum" idx="12"/>
+          </p:nvPr>
+        </p:nvSpPr>
+        <p:spPr>
+          <a:xfrm>
+            <a:off x="4297650" y="4602875"/>
+            <a:ext cx="548700" cy="333600"/>
+          </a:xfrm>
+          <a:prstGeom prst="rect">
+            <a:avLst/>
+          </a:prstGeom>
+        </p:spPr>
+        <p:txBody>
+          <a:bodyPr spcFirstLastPara="1" wrap="square" lIns="91425" tIns="91425" rIns="91425" bIns="91425" anchor="t" anchorCtr="0">
+            <a:noAutofit/>
+          </a:bodyPr>
+          <a:lstStyle/>
+          <a:p>
+            <a:pPr marL="0" lvl="0" indent="0" algn="ctr" rtl="0">
+              <a:spcBef>
+                <a:spcPts val="0"/>
+              </a:spcBef>
+              <a:spcAft>
+                <a:spcPts val="0"/>
+              </a:spcAft>
+              <a:buNone/>
+            </a:pPr>
+            <a:r>
+              <a:rPr lang="en" dirty="0"/>
+              <a:t>8</a:t>
+            </a:r>
+            <a:endParaRPr dirty="0"/>
+          </a:p>
+        </p:txBody>
+      </p:sp>
+      <p:sp>
+        <p:nvSpPr>
+          <p:cNvPr id="11" name="文字方塊 10">
+            <a:extLst>
+              <a:ext uri="{FF2B5EF4-FFF2-40B4-BE49-F238E27FC236}">
+                <a16:creationId xmlns:a16="http://schemas.microsoft.com/office/drawing/2014/main" id="{9038CC45-9AD5-43AD-9861-EDC4FE1629A2}"/>
+              </a:ext>
+            </a:extLst>
+          </p:cNvPr>
+          <p:cNvSpPr txBox="1"/>
+          <p:nvPr/>
+        </p:nvSpPr>
+        <p:spPr>
+          <a:xfrm>
+            <a:off x="2286000" y="376464"/>
+            <a:ext cx="4572000" cy="523220"/>
+          </a:xfrm>
+          <a:prstGeom prst="rect">
+            <a:avLst/>
+          </a:prstGeom>
+          <a:noFill/>
+        </p:spPr>
+        <p:txBody>
+          <a:bodyPr wrap="square">
+            <a:spAutoFit/>
+          </a:bodyPr>
+          <a:lstStyle/>
+          <a:p>
+            <a:pPr algn="ctr"/>
+            <a:r>
+              <a:rPr lang="zh-TW" altLang="en-US" sz="2800" dirty="0">
+                <a:ln w="0"/>
+                <a:gradFill>
+                  <a:gsLst>
+                    <a:gs pos="21000">
+                      <a:srgbClr val="53575C"/>
+                    </a:gs>
+                    <a:gs pos="88000">
+                      <a:srgbClr val="C5C7CA"/>
+                    </a:gs>
+                  </a:gsLst>
+                  <a:lin ang="5400000"/>
+                </a:gradFill>
+              </a:rPr>
+              <a:t>圖表展示</a:t>
+            </a:r>
+          </a:p>
+        </p:txBody>
+      </p:sp>
+      <p:pic>
+        <p:nvPicPr>
+          <p:cNvPr id="10" name="圖片 9">
+            <a:extLst>
+              <a:ext uri="{FF2B5EF4-FFF2-40B4-BE49-F238E27FC236}">
+                <a16:creationId xmlns:a16="http://schemas.microsoft.com/office/drawing/2014/main" id="{627E0BA1-7A81-A5EA-7771-85FBE28CA9D8}"/>
+              </a:ext>
+            </a:extLst>
+          </p:cNvPr>
+          <p:cNvPicPr>
+            <a:picLocks noChangeAspect="1"/>
+          </p:cNvPicPr>
+          <p:nvPr/>
+        </p:nvPicPr>
+        <p:blipFill>
+          <a:blip r:embed="rId3"/>
+          <a:stretch>
+            <a:fillRect/>
+          </a:stretch>
+        </p:blipFill>
+        <p:spPr>
+          <a:xfrm>
+            <a:off x="210660" y="899684"/>
+            <a:ext cx="4348800" cy="3474345"/>
+          </a:xfrm>
+          <a:prstGeom prst="rect">
+            <a:avLst/>
+          </a:prstGeom>
+          <a:ln w="12700">
+            <a:solidFill>
+              <a:schemeClr val="bg1">
+                <a:lumMod val="10000"/>
+              </a:schemeClr>
+            </a:solidFill>
+          </a:ln>
+        </p:spPr>
+      </p:pic>
+      <p:pic>
+        <p:nvPicPr>
+          <p:cNvPr id="12" name="圖片 11">
+            <a:extLst>
+              <a:ext uri="{FF2B5EF4-FFF2-40B4-BE49-F238E27FC236}">
+                <a16:creationId xmlns:a16="http://schemas.microsoft.com/office/drawing/2014/main" id="{B81F9596-BA47-B826-C0E8-DB9FFB92DCD2}"/>
+              </a:ext>
+            </a:extLst>
+          </p:cNvPr>
+          <p:cNvPicPr>
+            <a:picLocks noChangeAspect="1"/>
+          </p:cNvPicPr>
+          <p:nvPr/>
+        </p:nvPicPr>
+        <p:blipFill>
+          <a:blip r:embed="rId4"/>
+          <a:stretch>
+            <a:fillRect/>
+          </a:stretch>
+        </p:blipFill>
+        <p:spPr>
+          <a:xfrm>
+            <a:off x="4583844" y="899716"/>
+            <a:ext cx="4349496" cy="3474313"/>
+          </a:xfrm>
+          <a:prstGeom prst="rect">
+            <a:avLst/>
+          </a:prstGeom>
+          <a:ln w="12700">
+            <a:solidFill>
+              <a:schemeClr val="bg1">
+                <a:lumMod val="10000"/>
+              </a:schemeClr>
+            </a:solidFill>
+          </a:ln>
+        </p:spPr>
+      </p:pic>
+    </p:spTree>
+    <p:extLst>
+      <p:ext uri="{BB962C8B-B14F-4D97-AF65-F5344CB8AC3E}">
+        <p14:creationId xmlns:p14="http://schemas.microsoft.com/office/powerpoint/2010/main" val="1050173502"/>
+      </p:ext>
+    </p:extLst>
   </p:cSld>
   <p:clrMapOvr>
     <a:masterClrMapping/>

</xml_diff>